<commit_message>
Figure 1 PPT: embed 10 twemoji icons (4 mascots, 3 cause, 3 repair)
</commit_message>
<xml_diff>
--- a/fig1_thesis.pptx
+++ b/fig1_thesis.pptx
@@ -3284,7 +3284,6 @@
             <a:solidFill>
               <a:srgbClr val="868E96"/>
             </a:solidFill>
-            <a:prstDash val="dash"/>
           </a:ln>
         </p:spPr>
         <p:style>
@@ -3307,7 +3306,65 @@
           <a:p>
             <a:pPr algn="ctr"/>
             <a:r>
-              <a:rPr sz="1300" b="0" i="1">
+              <a:rPr sz="1200" b="0" i="0">
+                <a:solidFill>
+                  <a:srgbClr val="212529"/>
+                </a:solidFill>
+              </a:rPr>
+              <a:t/>
+            </a:r>
+          </a:p>
+        </p:txBody>
+      </p:sp>
+      <p:pic>
+        <p:nvPicPr>
+          <p:cNvPr id="6" name="Picture 5" descr="m1.png"/>
+          <p:cNvPicPr>
+            <a:picLocks noChangeAspect="1"/>
+          </p:cNvPicPr>
+          <p:nvPr/>
+        </p:nvPicPr>
+        <p:blipFill>
+          <a:blip r:embed="rId2"/>
+          <a:stretch>
+            <a:fillRect/>
+          </a:stretch>
+        </p:blipFill>
+        <p:spPr>
+          <a:xfrm>
+            <a:off x="3657600" y="914400"/>
+            <a:ext cx="777240" cy="777240"/>
+          </a:xfrm>
+          <a:prstGeom prst="rect">
+            <a:avLst/>
+          </a:prstGeom>
+        </p:spPr>
+      </p:pic>
+      <p:sp>
+        <p:nvSpPr>
+          <p:cNvPr id="7" name="TextBox 6"/>
+          <p:cNvSpPr txBox="1"/>
+          <p:nvPr/>
+        </p:nvSpPr>
+        <p:spPr>
+          <a:xfrm>
+            <a:off x="2926080" y="1709928"/>
+            <a:ext cx="2240280" cy="164592"/>
+          </a:xfrm>
+          <a:prstGeom prst="rect">
+            <a:avLst/>
+          </a:prstGeom>
+          <a:noFill/>
+        </p:spPr>
+        <p:txBody>
+          <a:bodyPr wrap="square">
+            <a:spAutoFit/>
+          </a:bodyPr>
+          <a:lstStyle/>
+          <a:p>
+            <a:pPr algn="ctr"/>
+            <a:r>
+              <a:rPr sz="1100" b="0" i="0">
                 <a:solidFill>
                   <a:srgbClr val="868E96"/>
                 </a:solidFill>
@@ -3315,22 +3372,11 @@
               <a:t>Model 1</a:t>
             </a:r>
           </a:p>
-          <a:p>
-            <a:pPr algn="ctr"/>
-            <a:r>
-              <a:rPr sz="1300" b="0" i="1">
-                <a:solidFill>
-                  <a:srgbClr val="868E96"/>
-                </a:solidFill>
-              </a:rPr>
-              <a:t>[DROP PNG HERE]</a:t>
-            </a:r>
-          </a:p>
-        </p:txBody>
-      </p:sp>
-      <p:sp>
-        <p:nvSpPr>
-          <p:cNvPr id="6" name="Rounded Rectangle 5"/>
+        </p:txBody>
+      </p:sp>
+      <p:sp>
+        <p:nvSpPr>
+          <p:cNvPr id="8" name="Rounded Rectangle 7"/>
           <p:cNvSpPr/>
           <p:nvPr/>
         </p:nvSpPr>
@@ -3383,7 +3429,7 @@
       </p:sp>
       <p:sp>
         <p:nvSpPr>
-          <p:cNvPr id="7" name="Rounded Rectangle 6"/>
+          <p:cNvPr id="9" name="Rounded Rectangle 8"/>
           <p:cNvSpPr/>
           <p:nvPr/>
         </p:nvSpPr>
@@ -3402,7 +3448,6 @@
             <a:solidFill>
               <a:srgbClr val="868E96"/>
             </a:solidFill>
-            <a:prstDash val="dash"/>
           </a:ln>
         </p:spPr>
         <p:style>
@@ -3425,7 +3470,65 @@
           <a:p>
             <a:pPr algn="ctr"/>
             <a:r>
-              <a:rPr sz="1300" b="0" i="1">
+              <a:rPr sz="1200" b="0" i="0">
+                <a:solidFill>
+                  <a:srgbClr val="212529"/>
+                </a:solidFill>
+              </a:rPr>
+              <a:t/>
+            </a:r>
+          </a:p>
+        </p:txBody>
+      </p:sp>
+      <p:pic>
+        <p:nvPicPr>
+          <p:cNvPr id="10" name="Picture 9" descr="m2.png"/>
+          <p:cNvPicPr>
+            <a:picLocks noChangeAspect="1"/>
+          </p:cNvPicPr>
+          <p:nvPr/>
+        </p:nvPicPr>
+        <p:blipFill>
+          <a:blip r:embed="rId3"/>
+          <a:stretch>
+            <a:fillRect/>
+          </a:stretch>
+        </p:blipFill>
+        <p:spPr>
+          <a:xfrm>
+            <a:off x="5943600" y="914400"/>
+            <a:ext cx="777240" cy="777240"/>
+          </a:xfrm>
+          <a:prstGeom prst="rect">
+            <a:avLst/>
+          </a:prstGeom>
+        </p:spPr>
+      </p:pic>
+      <p:sp>
+        <p:nvSpPr>
+          <p:cNvPr id="11" name="TextBox 10"/>
+          <p:cNvSpPr txBox="1"/>
+          <p:nvPr/>
+        </p:nvSpPr>
+        <p:spPr>
+          <a:xfrm>
+            <a:off x="5212080" y="1709928"/>
+            <a:ext cx="2240280" cy="164592"/>
+          </a:xfrm>
+          <a:prstGeom prst="rect">
+            <a:avLst/>
+          </a:prstGeom>
+          <a:noFill/>
+        </p:spPr>
+        <p:txBody>
+          <a:bodyPr wrap="square">
+            <a:spAutoFit/>
+          </a:bodyPr>
+          <a:lstStyle/>
+          <a:p>
+            <a:pPr algn="ctr"/>
+            <a:r>
+              <a:rPr sz="1100" b="0" i="0">
                 <a:solidFill>
                   <a:srgbClr val="868E96"/>
                 </a:solidFill>
@@ -3433,22 +3536,11 @@
               <a:t>Model 2</a:t>
             </a:r>
           </a:p>
-          <a:p>
-            <a:pPr algn="ctr"/>
-            <a:r>
-              <a:rPr sz="1300" b="0" i="1">
-                <a:solidFill>
-                  <a:srgbClr val="868E96"/>
-                </a:solidFill>
-              </a:rPr>
-              <a:t>[DROP PNG HERE]</a:t>
-            </a:r>
-          </a:p>
-        </p:txBody>
-      </p:sp>
-      <p:sp>
-        <p:nvSpPr>
-          <p:cNvPr id="8" name="Rounded Rectangle 7"/>
+        </p:txBody>
+      </p:sp>
+      <p:sp>
+        <p:nvSpPr>
+          <p:cNvPr id="12" name="Rounded Rectangle 11"/>
           <p:cNvSpPr/>
           <p:nvPr/>
         </p:nvSpPr>
@@ -3501,7 +3593,7 @@
       </p:sp>
       <p:sp>
         <p:nvSpPr>
-          <p:cNvPr id="9" name="Rounded Rectangle 8"/>
+          <p:cNvPr id="13" name="Rounded Rectangle 12"/>
           <p:cNvSpPr/>
           <p:nvPr/>
         </p:nvSpPr>
@@ -3520,7 +3612,6 @@
             <a:solidFill>
               <a:srgbClr val="868E96"/>
             </a:solidFill>
-            <a:prstDash val="dash"/>
           </a:ln>
         </p:spPr>
         <p:style>
@@ -3543,7 +3634,65 @@
           <a:p>
             <a:pPr algn="ctr"/>
             <a:r>
-              <a:rPr sz="1300" b="0" i="1">
+              <a:rPr sz="1200" b="0" i="0">
+                <a:solidFill>
+                  <a:srgbClr val="212529"/>
+                </a:solidFill>
+              </a:rPr>
+              <a:t/>
+            </a:r>
+          </a:p>
+        </p:txBody>
+      </p:sp>
+      <p:pic>
+        <p:nvPicPr>
+          <p:cNvPr id="14" name="Picture 13" descr="m3.png"/>
+          <p:cNvPicPr>
+            <a:picLocks noChangeAspect="1"/>
+          </p:cNvPicPr>
+          <p:nvPr/>
+        </p:nvPicPr>
+        <p:blipFill>
+          <a:blip r:embed="rId4"/>
+          <a:stretch>
+            <a:fillRect/>
+          </a:stretch>
+        </p:blipFill>
+        <p:spPr>
+          <a:xfrm>
+            <a:off x="8229600" y="914400"/>
+            <a:ext cx="777240" cy="777240"/>
+          </a:xfrm>
+          <a:prstGeom prst="rect">
+            <a:avLst/>
+          </a:prstGeom>
+        </p:spPr>
+      </p:pic>
+      <p:sp>
+        <p:nvSpPr>
+          <p:cNvPr id="15" name="TextBox 14"/>
+          <p:cNvSpPr txBox="1"/>
+          <p:nvPr/>
+        </p:nvSpPr>
+        <p:spPr>
+          <a:xfrm>
+            <a:off x="7498079" y="1709928"/>
+            <a:ext cx="2240280" cy="164592"/>
+          </a:xfrm>
+          <a:prstGeom prst="rect">
+            <a:avLst/>
+          </a:prstGeom>
+          <a:noFill/>
+        </p:spPr>
+        <p:txBody>
+          <a:bodyPr wrap="square">
+            <a:spAutoFit/>
+          </a:bodyPr>
+          <a:lstStyle/>
+          <a:p>
+            <a:pPr algn="ctr"/>
+            <a:r>
+              <a:rPr sz="1100" b="0" i="0">
                 <a:solidFill>
                   <a:srgbClr val="868E96"/>
                 </a:solidFill>
@@ -3551,22 +3700,11 @@
               <a:t>Model 3</a:t>
             </a:r>
           </a:p>
-          <a:p>
-            <a:pPr algn="ctr"/>
-            <a:r>
-              <a:rPr sz="1300" b="0" i="1">
-                <a:solidFill>
-                  <a:srgbClr val="868E96"/>
-                </a:solidFill>
-              </a:rPr>
-              <a:t>[DROP PNG HERE]</a:t>
-            </a:r>
-          </a:p>
-        </p:txBody>
-      </p:sp>
-      <p:sp>
-        <p:nvSpPr>
-          <p:cNvPr id="10" name="Rounded Rectangle 9"/>
+        </p:txBody>
+      </p:sp>
+      <p:sp>
+        <p:nvSpPr>
+          <p:cNvPr id="16" name="Rounded Rectangle 15"/>
           <p:cNvSpPr/>
           <p:nvPr/>
         </p:nvSpPr>
@@ -3619,7 +3757,7 @@
       </p:sp>
       <p:sp>
         <p:nvSpPr>
-          <p:cNvPr id="11" name="Rounded Rectangle 10"/>
+          <p:cNvPr id="17" name="Rounded Rectangle 16"/>
           <p:cNvSpPr/>
           <p:nvPr/>
         </p:nvSpPr>
@@ -3638,7 +3776,6 @@
             <a:solidFill>
               <a:srgbClr val="868E96"/>
             </a:solidFill>
-            <a:prstDash val="dash"/>
           </a:ln>
         </p:spPr>
         <p:style>
@@ -3661,7 +3798,65 @@
           <a:p>
             <a:pPr algn="ctr"/>
             <a:r>
-              <a:rPr sz="1300" b="0" i="1">
+              <a:rPr sz="1200" b="0" i="0">
+                <a:solidFill>
+                  <a:srgbClr val="212529"/>
+                </a:solidFill>
+              </a:rPr>
+              <a:t/>
+            </a:r>
+          </a:p>
+        </p:txBody>
+      </p:sp>
+      <p:pic>
+        <p:nvPicPr>
+          <p:cNvPr id="18" name="Picture 17" descr="m4.png"/>
+          <p:cNvPicPr>
+            <a:picLocks noChangeAspect="1"/>
+          </p:cNvPicPr>
+          <p:nvPr/>
+        </p:nvPicPr>
+        <p:blipFill>
+          <a:blip r:embed="rId5"/>
+          <a:stretch>
+            <a:fillRect/>
+          </a:stretch>
+        </p:blipFill>
+        <p:spPr>
+          <a:xfrm>
+            <a:off x="10515600" y="914400"/>
+            <a:ext cx="777240" cy="777240"/>
+          </a:xfrm>
+          <a:prstGeom prst="rect">
+            <a:avLst/>
+          </a:prstGeom>
+        </p:spPr>
+      </p:pic>
+      <p:sp>
+        <p:nvSpPr>
+          <p:cNvPr id="19" name="TextBox 18"/>
+          <p:cNvSpPr txBox="1"/>
+          <p:nvPr/>
+        </p:nvSpPr>
+        <p:spPr>
+          <a:xfrm>
+            <a:off x="9784080" y="1709928"/>
+            <a:ext cx="2240280" cy="164592"/>
+          </a:xfrm>
+          <a:prstGeom prst="rect">
+            <a:avLst/>
+          </a:prstGeom>
+          <a:noFill/>
+        </p:spPr>
+        <p:txBody>
+          <a:bodyPr wrap="square">
+            <a:spAutoFit/>
+          </a:bodyPr>
+          <a:lstStyle/>
+          <a:p>
+            <a:pPr algn="ctr"/>
+            <a:r>
+              <a:rPr sz="1100" b="0" i="0">
                 <a:solidFill>
                   <a:srgbClr val="868E96"/>
                 </a:solidFill>
@@ -3669,22 +3864,11 @@
               <a:t>Model 4</a:t>
             </a:r>
           </a:p>
-          <a:p>
-            <a:pPr algn="ctr"/>
-            <a:r>
-              <a:rPr sz="1300" b="0" i="1">
-                <a:solidFill>
-                  <a:srgbClr val="868E96"/>
-                </a:solidFill>
-              </a:rPr>
-              <a:t>[DROP PNG HERE]</a:t>
-            </a:r>
-          </a:p>
-        </p:txBody>
-      </p:sp>
-      <p:sp>
-        <p:nvSpPr>
-          <p:cNvPr id="12" name="Rounded Rectangle 11"/>
+        </p:txBody>
+      </p:sp>
+      <p:sp>
+        <p:nvSpPr>
+          <p:cNvPr id="20" name="Rounded Rectangle 19"/>
           <p:cNvSpPr/>
           <p:nvPr/>
         </p:nvSpPr>
@@ -3737,7 +3921,7 @@
       </p:sp>
       <p:sp>
         <p:nvSpPr>
-          <p:cNvPr id="13" name="Rounded Rectangle 12"/>
+          <p:cNvPr id="21" name="Rounded Rectangle 20"/>
           <p:cNvSpPr/>
           <p:nvPr/>
         </p:nvSpPr>
@@ -3790,7 +3974,7 @@
       </p:sp>
       <p:sp>
         <p:nvSpPr>
-          <p:cNvPr id="14" name="Rounded Rectangle 13"/>
+          <p:cNvPr id="22" name="Rounded Rectangle 21"/>
           <p:cNvSpPr/>
           <p:nvPr/>
         </p:nvSpPr>
@@ -3843,14 +4027,14 @@
       </p:sp>
       <p:sp>
         <p:nvSpPr>
-          <p:cNvPr id="15" name="TextBox 14"/>
+          <p:cNvPr id="23" name="TextBox 22"/>
           <p:cNvSpPr txBox="1"/>
           <p:nvPr/>
         </p:nvSpPr>
         <p:spPr>
           <a:xfrm>
-            <a:off x="274320" y="3063240"/>
-            <a:ext cx="3721607" cy="320040"/>
+            <a:off x="320040" y="3063240"/>
+            <a:ext cx="3630168" cy="320040"/>
           </a:xfrm>
           <a:prstGeom prst="rect">
             <a:avLst/>
@@ -3875,70 +4059,40 @@
           </a:p>
         </p:txBody>
       </p:sp>
-      <p:sp>
-        <p:nvSpPr>
-          <p:cNvPr id="16" name="Rounded Rectangle 15"/>
-          <p:cNvSpPr/>
+      <p:pic>
+        <p:nvPicPr>
+          <p:cNvPr id="24" name="Picture 23" descr="c1.png"/>
+          <p:cNvPicPr>
+            <a:picLocks noChangeAspect="1"/>
+          </p:cNvPicPr>
           <p:nvPr/>
-        </p:nvSpPr>
-        <p:spPr>
-          <a:xfrm>
-            <a:off x="320040" y="3474720"/>
-            <a:ext cx="1463040" cy="1051560"/>
-          </a:xfrm>
-          <a:prstGeom prst="roundRect">
+        </p:nvPicPr>
+        <p:blipFill>
+          <a:blip r:embed="rId6"/>
+          <a:stretch>
+            <a:fillRect/>
+          </a:stretch>
+        </p:blipFill>
+        <p:spPr>
+          <a:xfrm>
+            <a:off x="457200" y="3611880"/>
+            <a:ext cx="960120" cy="960120"/>
+          </a:xfrm>
+          <a:prstGeom prst="rect">
             <a:avLst/>
           </a:prstGeom>
-          <a:solidFill>
-            <a:srgbClr val="FFFFFF"/>
-          </a:solidFill>
-          <a:ln w="19050">
-            <a:solidFill>
-              <a:srgbClr val="868E96"/>
-            </a:solidFill>
-            <a:prstDash val="dash"/>
-          </a:ln>
-        </p:spPr>
-        <p:style>
-          <a:lnRef idx="1">
-            <a:schemeClr val="accent1"/>
-          </a:lnRef>
-          <a:fillRef idx="3">
-            <a:schemeClr val="accent1"/>
-          </a:fillRef>
-          <a:effectRef idx="2">
-            <a:schemeClr val="accent1"/>
-          </a:effectRef>
-          <a:fontRef idx="minor">
-            <a:schemeClr val="lt1"/>
-          </a:fontRef>
-        </p:style>
-        <p:txBody>
-          <a:bodyPr rtlCol="0" anchor="ctr" lIns="73152" rIns="73152" wrap="square"/>
-          <a:lstStyle/>
-          <a:p>
-            <a:pPr algn="ctr"/>
-            <a:r>
-              <a:rPr sz="1200" b="0" i="1">
-                <a:solidFill>
-                  <a:srgbClr val="868E96"/>
-                </a:solidFill>
-              </a:rPr>
-              <a:t>[PIC: empty drawer / 💭]</a:t>
-            </a:r>
-          </a:p>
-        </p:txBody>
-      </p:sp>
-      <p:sp>
-        <p:nvSpPr>
-          <p:cNvPr id="17" name="TextBox 16"/>
+        </p:spPr>
+      </p:pic>
+      <p:sp>
+        <p:nvSpPr>
+          <p:cNvPr id="25" name="TextBox 24"/>
           <p:cNvSpPr txBox="1"/>
           <p:nvPr/>
         </p:nvSpPr>
         <p:spPr>
           <a:xfrm>
-            <a:off x="1874520" y="3520440"/>
-            <a:ext cx="2075687" cy="914400"/>
+            <a:off x="1600200" y="3611880"/>
+            <a:ext cx="2350007" cy="914400"/>
           </a:xfrm>
           <a:prstGeom prst="rect">
             <a:avLst/>
@@ -3976,14 +4130,14 @@
       </p:sp>
       <p:sp>
         <p:nvSpPr>
-          <p:cNvPr id="18" name="TextBox 17"/>
+          <p:cNvPr id="26" name="TextBox 25"/>
           <p:cNvSpPr txBox="1"/>
           <p:nvPr/>
         </p:nvSpPr>
         <p:spPr>
           <a:xfrm>
-            <a:off x="274320" y="4572000"/>
-            <a:ext cx="3721607" cy="228600"/>
+            <a:off x="320040" y="4572000"/>
+            <a:ext cx="3630168" cy="228600"/>
           </a:xfrm>
           <a:prstGeom prst="rect">
             <a:avLst/>
@@ -4010,7 +4164,7 @@
       </p:sp>
       <p:sp>
         <p:nvSpPr>
-          <p:cNvPr id="19" name="Rounded Rectangle 18"/>
+          <p:cNvPr id="27" name="Rounded Rectangle 26"/>
           <p:cNvSpPr/>
           <p:nvPr/>
         </p:nvSpPr>
@@ -4063,14 +4217,14 @@
       </p:sp>
       <p:sp>
         <p:nvSpPr>
-          <p:cNvPr id="20" name="TextBox 19"/>
+          <p:cNvPr id="28" name="TextBox 27"/>
           <p:cNvSpPr txBox="1"/>
           <p:nvPr/>
         </p:nvSpPr>
         <p:spPr>
           <a:xfrm>
-            <a:off x="4270247" y="3063240"/>
-            <a:ext cx="3721607" cy="320040"/>
+            <a:off x="4315968" y="3063240"/>
+            <a:ext cx="3630168" cy="320040"/>
           </a:xfrm>
           <a:prstGeom prst="rect">
             <a:avLst/>
@@ -4095,70 +4249,40 @@
           </a:p>
         </p:txBody>
       </p:sp>
-      <p:sp>
-        <p:nvSpPr>
-          <p:cNvPr id="21" name="Rounded Rectangle 20"/>
-          <p:cNvSpPr/>
+      <p:pic>
+        <p:nvPicPr>
+          <p:cNvPr id="29" name="Picture 28" descr="c2.png"/>
+          <p:cNvPicPr>
+            <a:picLocks noChangeAspect="1"/>
+          </p:cNvPicPr>
           <p:nvPr/>
-        </p:nvSpPr>
-        <p:spPr>
-          <a:xfrm>
-            <a:off x="4315968" y="3474720"/>
-            <a:ext cx="1463040" cy="1051560"/>
-          </a:xfrm>
-          <a:prstGeom prst="roundRect">
+        </p:nvPicPr>
+        <p:blipFill>
+          <a:blip r:embed="rId7"/>
+          <a:stretch>
+            <a:fillRect/>
+          </a:stretch>
+        </p:blipFill>
+        <p:spPr>
+          <a:xfrm>
+            <a:off x="4453127" y="3611880"/>
+            <a:ext cx="960120" cy="960120"/>
+          </a:xfrm>
+          <a:prstGeom prst="rect">
             <a:avLst/>
           </a:prstGeom>
-          <a:solidFill>
-            <a:srgbClr val="FFFFFF"/>
-          </a:solidFill>
-          <a:ln w="19050">
-            <a:solidFill>
-              <a:srgbClr val="868E96"/>
-            </a:solidFill>
-            <a:prstDash val="dash"/>
-          </a:ln>
-        </p:spPr>
-        <p:style>
-          <a:lnRef idx="1">
-            <a:schemeClr val="accent1"/>
-          </a:lnRef>
-          <a:fillRef idx="3">
-            <a:schemeClr val="accent1"/>
-          </a:fillRef>
-          <a:effectRef idx="2">
-            <a:schemeClr val="accent1"/>
-          </a:effectRef>
-          <a:fontRef idx="minor">
-            <a:schemeClr val="lt1"/>
-          </a:fontRef>
-        </p:style>
-        <p:txBody>
-          <a:bodyPr rtlCol="0" anchor="ctr" lIns="73152" rIns="73152" wrap="square"/>
-          <a:lstStyle/>
-          <a:p>
-            <a:pPr algn="ctr"/>
-            <a:r>
-              <a:rPr sz="1200" b="0" i="1">
-                <a:solidFill>
-                  <a:srgbClr val="868E96"/>
-                </a:solidFill>
-              </a:rPr>
-              <a:t>[PIC: maze / shuffled words]</a:t>
-            </a:r>
-          </a:p>
-        </p:txBody>
-      </p:sp>
-      <p:sp>
-        <p:nvSpPr>
-          <p:cNvPr id="22" name="TextBox 21"/>
+        </p:spPr>
+      </p:pic>
+      <p:sp>
+        <p:nvSpPr>
+          <p:cNvPr id="30" name="TextBox 29"/>
           <p:cNvSpPr txBox="1"/>
           <p:nvPr/>
         </p:nvSpPr>
         <p:spPr>
           <a:xfrm>
-            <a:off x="5870448" y="3520440"/>
-            <a:ext cx="2075687" cy="914400"/>
+            <a:off x="5596127" y="3611880"/>
+            <a:ext cx="2350007" cy="914400"/>
           </a:xfrm>
           <a:prstGeom prst="rect">
             <a:avLst/>
@@ -4196,14 +4320,14 @@
       </p:sp>
       <p:sp>
         <p:nvSpPr>
-          <p:cNvPr id="23" name="TextBox 22"/>
+          <p:cNvPr id="31" name="TextBox 30"/>
           <p:cNvSpPr txBox="1"/>
           <p:nvPr/>
         </p:nvSpPr>
         <p:spPr>
           <a:xfrm>
-            <a:off x="4270247" y="4572000"/>
-            <a:ext cx="3721607" cy="228600"/>
+            <a:off x="4315968" y="4572000"/>
+            <a:ext cx="3630168" cy="228600"/>
           </a:xfrm>
           <a:prstGeom prst="rect">
             <a:avLst/>
@@ -4230,7 +4354,7 @@
       </p:sp>
       <p:sp>
         <p:nvSpPr>
-          <p:cNvPr id="24" name="Rounded Rectangle 23"/>
+          <p:cNvPr id="32" name="Rounded Rectangle 31"/>
           <p:cNvSpPr/>
           <p:nvPr/>
         </p:nvSpPr>
@@ -4283,14 +4407,14 @@
       </p:sp>
       <p:sp>
         <p:nvSpPr>
-          <p:cNvPr id="25" name="TextBox 24"/>
+          <p:cNvPr id="33" name="TextBox 32"/>
           <p:cNvSpPr txBox="1"/>
           <p:nvPr/>
         </p:nvSpPr>
         <p:spPr>
           <a:xfrm>
-            <a:off x="8266175" y="3063240"/>
-            <a:ext cx="3721607" cy="320040"/>
+            <a:off x="8311895" y="3063240"/>
+            <a:ext cx="3630168" cy="320040"/>
           </a:xfrm>
           <a:prstGeom prst="rect">
             <a:avLst/>
@@ -4315,70 +4439,40 @@
           </a:p>
         </p:txBody>
       </p:sp>
-      <p:sp>
-        <p:nvSpPr>
-          <p:cNvPr id="26" name="Rounded Rectangle 25"/>
-          <p:cNvSpPr/>
+      <p:pic>
+        <p:nvPicPr>
+          <p:cNvPr id="34" name="Picture 33" descr="c3.png"/>
+          <p:cNvPicPr>
+            <a:picLocks noChangeAspect="1"/>
+          </p:cNvPicPr>
           <p:nvPr/>
-        </p:nvSpPr>
-        <p:spPr>
-          <a:xfrm>
-            <a:off x="8311895" y="3474720"/>
-            <a:ext cx="1463040" cy="1051560"/>
-          </a:xfrm>
-          <a:prstGeom prst="roundRect">
+        </p:nvPicPr>
+        <p:blipFill>
+          <a:blip r:embed="rId8"/>
+          <a:stretch>
+            <a:fillRect/>
+          </a:stretch>
+        </p:blipFill>
+        <p:spPr>
+          <a:xfrm>
+            <a:off x="8449055" y="3611880"/>
+            <a:ext cx="960120" cy="960120"/>
+          </a:xfrm>
+          <a:prstGeom prst="rect">
             <a:avLst/>
           </a:prstGeom>
-          <a:solidFill>
-            <a:srgbClr val="FFFFFF"/>
-          </a:solidFill>
-          <a:ln w="19050">
-            <a:solidFill>
-              <a:srgbClr val="868E96"/>
-            </a:solidFill>
-            <a:prstDash val="dash"/>
-          </a:ln>
-        </p:spPr>
-        <p:style>
-          <a:lnRef idx="1">
-            <a:schemeClr val="accent1"/>
-          </a:lnRef>
-          <a:fillRef idx="3">
-            <a:schemeClr val="accent1"/>
-          </a:fillRef>
-          <a:effectRef idx="2">
-            <a:schemeClr val="accent1"/>
-          </a:effectRef>
-          <a:fontRef idx="minor">
-            <a:schemeClr val="lt1"/>
-          </a:fontRef>
-        </p:style>
-        <p:txBody>
-          <a:bodyPr rtlCol="0" anchor="ctr" lIns="73152" rIns="73152" wrap="square"/>
-          <a:lstStyle/>
-          <a:p>
-            <a:pPr algn="ctr"/>
-            <a:r>
-              <a:rPr sz="1200" b="0" i="1">
-                <a:solidFill>
-                  <a:srgbClr val="868E96"/>
-                </a:solidFill>
-              </a:rPr>
-              <a:t>[PIC: megaphone / trickster]</a:t>
-            </a:r>
-          </a:p>
-        </p:txBody>
-      </p:sp>
-      <p:sp>
-        <p:nvSpPr>
-          <p:cNvPr id="27" name="TextBox 26"/>
+        </p:spPr>
+      </p:pic>
+      <p:sp>
+        <p:nvSpPr>
+          <p:cNvPr id="35" name="TextBox 34"/>
           <p:cNvSpPr txBox="1"/>
           <p:nvPr/>
         </p:nvSpPr>
         <p:spPr>
           <a:xfrm>
-            <a:off x="9866375" y="3520440"/>
-            <a:ext cx="2075687" cy="914400"/>
+            <a:off x="9592055" y="3611880"/>
+            <a:ext cx="2350007" cy="914400"/>
           </a:xfrm>
           <a:prstGeom prst="rect">
             <a:avLst/>
@@ -4416,14 +4510,14 @@
       </p:sp>
       <p:sp>
         <p:nvSpPr>
-          <p:cNvPr id="28" name="TextBox 27"/>
+          <p:cNvPr id="36" name="TextBox 35"/>
           <p:cNvSpPr txBox="1"/>
           <p:nvPr/>
         </p:nvSpPr>
         <p:spPr>
           <a:xfrm>
-            <a:off x="8266175" y="4572000"/>
-            <a:ext cx="3721607" cy="228600"/>
+            <a:off x="8311895" y="4572000"/>
+            <a:ext cx="3630168" cy="228600"/>
           </a:xfrm>
           <a:prstGeom prst="rect">
             <a:avLst/>
@@ -4450,7 +4544,7 @@
       </p:sp>
       <p:cxnSp>
         <p:nvCxnSpPr>
-          <p:cNvPr id="29" name="Connector 28"/>
+          <p:cNvPr id="37" name="Connector 36"/>
           <p:cNvCxnSpPr/>
           <p:nvPr/>
         </p:nvCxnSpPr>
@@ -4486,7 +4580,7 @@
       </p:cxnSp>
       <p:cxnSp>
         <p:nvCxnSpPr>
-          <p:cNvPr id="30" name="Connector 29"/>
+          <p:cNvPr id="38" name="Connector 37"/>
           <p:cNvCxnSpPr/>
           <p:nvPr/>
         </p:nvCxnSpPr>
@@ -4522,7 +4616,7 @@
       </p:cxnSp>
       <p:cxnSp>
         <p:nvCxnSpPr>
-          <p:cNvPr id="31" name="Connector 30"/>
+          <p:cNvPr id="39" name="Connector 38"/>
           <p:cNvCxnSpPr/>
           <p:nvPr/>
         </p:nvCxnSpPr>
@@ -4558,7 +4652,7 @@
       </p:cxnSp>
       <p:sp>
         <p:nvSpPr>
-          <p:cNvPr id="32" name="Rounded Rectangle 31"/>
+          <p:cNvPr id="40" name="Rounded Rectangle 39"/>
           <p:cNvSpPr/>
           <p:nvPr/>
         </p:nvSpPr>
@@ -4611,14 +4705,14 @@
       </p:sp>
       <p:sp>
         <p:nvSpPr>
-          <p:cNvPr id="33" name="TextBox 32"/>
+          <p:cNvPr id="41" name="TextBox 40"/>
           <p:cNvSpPr txBox="1"/>
           <p:nvPr/>
         </p:nvSpPr>
         <p:spPr>
           <a:xfrm>
-            <a:off x="274320" y="5120640"/>
-            <a:ext cx="3721607" cy="274320"/>
+            <a:off x="320040" y="5120640"/>
+            <a:ext cx="3630168" cy="274320"/>
           </a:xfrm>
           <a:prstGeom prst="rect">
             <a:avLst/>
@@ -4643,80 +4737,39 @@
           </a:p>
         </p:txBody>
       </p:sp>
-      <p:sp>
-        <p:nvSpPr>
-          <p:cNvPr id="34" name="Rounded Rectangle 33"/>
-          <p:cNvSpPr/>
+      <p:pic>
+        <p:nvPicPr>
+          <p:cNvPr id="42" name="Picture 41" descr="r1.png"/>
+          <p:cNvPicPr>
+            <a:picLocks noChangeAspect="1"/>
+          </p:cNvPicPr>
           <p:nvPr/>
-        </p:nvSpPr>
-        <p:spPr>
-          <a:xfrm>
-            <a:off x="320040" y="5394960"/>
-            <a:ext cx="868680" cy="685800"/>
-          </a:xfrm>
-          <a:prstGeom prst="roundRect">
+        </p:nvPicPr>
+        <p:blipFill>
+          <a:blip r:embed="rId9"/>
+          <a:stretch>
+            <a:fillRect/>
+          </a:stretch>
+        </p:blipFill>
+        <p:spPr>
+          <a:xfrm>
+            <a:off x="457200" y="5440680"/>
+            <a:ext cx="640080" cy="640080"/>
+          </a:xfrm>
+          <a:prstGeom prst="rect">
             <a:avLst/>
           </a:prstGeom>
-          <a:solidFill>
-            <a:srgbClr val="FFFFFF"/>
-          </a:solidFill>
-          <a:ln w="19050">
-            <a:solidFill>
-              <a:srgbClr val="868E96"/>
-            </a:solidFill>
-            <a:prstDash val="dash"/>
-          </a:ln>
-        </p:spPr>
-        <p:style>
-          <a:lnRef idx="1">
-            <a:schemeClr val="accent1"/>
-          </a:lnRef>
-          <a:fillRef idx="3">
-            <a:schemeClr val="accent1"/>
-          </a:fillRef>
-          <a:effectRef idx="2">
-            <a:schemeClr val="accent1"/>
-          </a:effectRef>
-          <a:fontRef idx="minor">
-            <a:schemeClr val="lt1"/>
-          </a:fontRef>
-        </p:style>
-        <p:txBody>
-          <a:bodyPr rtlCol="0" anchor="ctr" lIns="73152" rIns="73152" wrap="square"/>
-          <a:lstStyle/>
-          <a:p>
-            <a:pPr algn="ctr"/>
-            <a:r>
-              <a:rPr sz="1100" b="0" i="1">
-                <a:solidFill>
-                  <a:srgbClr val="868E96"/>
-                </a:solidFill>
-              </a:rPr>
-              <a:t>[PIC:</a:t>
-            </a:r>
-          </a:p>
-          <a:p>
-            <a:pPr algn="ctr"/>
-            <a:r>
-              <a:rPr sz="1100" b="0" i="1">
-                <a:solidFill>
-                  <a:srgbClr val="868E96"/>
-                </a:solidFill>
-              </a:rPr>
-              <a:t>📚 RAG]</a:t>
-            </a:r>
-          </a:p>
-        </p:txBody>
-      </p:sp>
-      <p:sp>
-        <p:nvSpPr>
-          <p:cNvPr id="35" name="TextBox 34"/>
+        </p:spPr>
+      </p:pic>
+      <p:sp>
+        <p:nvSpPr>
+          <p:cNvPr id="43" name="TextBox 42"/>
           <p:cNvSpPr txBox="1"/>
           <p:nvPr/>
         </p:nvSpPr>
         <p:spPr>
           <a:xfrm>
-            <a:off x="1280160" y="5440680"/>
+            <a:off x="1234439" y="5440680"/>
             <a:ext cx="2715768" cy="640080"/>
           </a:xfrm>
           <a:prstGeom prst="rect">
@@ -4755,7 +4808,7 @@
       </p:sp>
       <p:sp>
         <p:nvSpPr>
-          <p:cNvPr id="36" name="Rounded Rectangle 35"/>
+          <p:cNvPr id="44" name="Rounded Rectangle 43"/>
           <p:cNvSpPr/>
           <p:nvPr/>
         </p:nvSpPr>
@@ -4808,14 +4861,14 @@
       </p:sp>
       <p:sp>
         <p:nvSpPr>
-          <p:cNvPr id="37" name="TextBox 36"/>
+          <p:cNvPr id="45" name="TextBox 44"/>
           <p:cNvSpPr txBox="1"/>
           <p:nvPr/>
         </p:nvSpPr>
         <p:spPr>
           <a:xfrm>
-            <a:off x="4270247" y="5120640"/>
-            <a:ext cx="3721607" cy="274320"/>
+            <a:off x="4315968" y="5120640"/>
+            <a:ext cx="3630168" cy="274320"/>
           </a:xfrm>
           <a:prstGeom prst="rect">
             <a:avLst/>
@@ -4840,80 +4893,39 @@
           </a:p>
         </p:txBody>
       </p:sp>
-      <p:sp>
-        <p:nvSpPr>
-          <p:cNvPr id="38" name="Rounded Rectangle 37"/>
-          <p:cNvSpPr/>
+      <p:pic>
+        <p:nvPicPr>
+          <p:cNvPr id="46" name="Picture 45" descr="r2.png"/>
+          <p:cNvPicPr>
+            <a:picLocks noChangeAspect="1"/>
+          </p:cNvPicPr>
           <p:nvPr/>
-        </p:nvSpPr>
-        <p:spPr>
-          <a:xfrm>
-            <a:off x="4315968" y="5394960"/>
-            <a:ext cx="868680" cy="685800"/>
-          </a:xfrm>
-          <a:prstGeom prst="roundRect">
+        </p:nvPicPr>
+        <p:blipFill>
+          <a:blip r:embed="rId10"/>
+          <a:stretch>
+            <a:fillRect/>
+          </a:stretch>
+        </p:blipFill>
+        <p:spPr>
+          <a:xfrm>
+            <a:off x="4453127" y="5440680"/>
+            <a:ext cx="640080" cy="640080"/>
+          </a:xfrm>
+          <a:prstGeom prst="rect">
             <a:avLst/>
           </a:prstGeom>
-          <a:solidFill>
-            <a:srgbClr val="FFFFFF"/>
-          </a:solidFill>
-          <a:ln w="19050">
-            <a:solidFill>
-              <a:srgbClr val="868E96"/>
-            </a:solidFill>
-            <a:prstDash val="dash"/>
-          </a:ln>
-        </p:spPr>
-        <p:style>
-          <a:lnRef idx="1">
-            <a:schemeClr val="accent1"/>
-          </a:lnRef>
-          <a:fillRef idx="3">
-            <a:schemeClr val="accent1"/>
-          </a:fillRef>
-          <a:effectRef idx="2">
-            <a:schemeClr val="accent1"/>
-          </a:effectRef>
-          <a:fontRef idx="minor">
-            <a:schemeClr val="lt1"/>
-          </a:fontRef>
-        </p:style>
-        <p:txBody>
-          <a:bodyPr rtlCol="0" anchor="ctr" lIns="73152" rIns="73152" wrap="square"/>
-          <a:lstStyle/>
-          <a:p>
-            <a:pPr algn="ctr"/>
-            <a:r>
-              <a:rPr sz="1100" b="0" i="1">
-                <a:solidFill>
-                  <a:srgbClr val="868E96"/>
-                </a:solidFill>
-              </a:rPr>
-              <a:t>[PIC:</a:t>
-            </a:r>
-          </a:p>
-          <a:p>
-            <a:pPr algn="ctr"/>
-            <a:r>
-              <a:rPr sz="1100" b="0" i="1">
-                <a:solidFill>
-                  <a:srgbClr val="868E96"/>
-                </a:solidFill>
-              </a:rPr>
-              <a:t>🔄 augment]</a:t>
-            </a:r>
-          </a:p>
-        </p:txBody>
-      </p:sp>
-      <p:sp>
-        <p:nvSpPr>
-          <p:cNvPr id="39" name="TextBox 38"/>
+        </p:spPr>
+      </p:pic>
+      <p:sp>
+        <p:nvSpPr>
+          <p:cNvPr id="47" name="TextBox 46"/>
           <p:cNvSpPr txBox="1"/>
           <p:nvPr/>
         </p:nvSpPr>
         <p:spPr>
           <a:xfrm>
-            <a:off x="5276088" y="5440680"/>
+            <a:off x="5230367" y="5440680"/>
             <a:ext cx="2715768" cy="640080"/>
           </a:xfrm>
           <a:prstGeom prst="rect">
@@ -4952,7 +4964,7 @@
       </p:sp>
       <p:sp>
         <p:nvSpPr>
-          <p:cNvPr id="40" name="Rounded Rectangle 39"/>
+          <p:cNvPr id="48" name="Rounded Rectangle 47"/>
           <p:cNvSpPr/>
           <p:nvPr/>
         </p:nvSpPr>
@@ -5005,14 +5017,14 @@
       </p:sp>
       <p:sp>
         <p:nvSpPr>
-          <p:cNvPr id="41" name="TextBox 40"/>
+          <p:cNvPr id="49" name="TextBox 48"/>
           <p:cNvSpPr txBox="1"/>
           <p:nvPr/>
         </p:nvSpPr>
         <p:spPr>
           <a:xfrm>
-            <a:off x="8266175" y="5120640"/>
-            <a:ext cx="3721607" cy="274320"/>
+            <a:off x="8311895" y="5120640"/>
+            <a:ext cx="3630168" cy="274320"/>
           </a:xfrm>
           <a:prstGeom prst="rect">
             <a:avLst/>
@@ -5037,80 +5049,39 @@
           </a:p>
         </p:txBody>
       </p:sp>
-      <p:sp>
-        <p:nvSpPr>
-          <p:cNvPr id="42" name="Rounded Rectangle 41"/>
-          <p:cNvSpPr/>
+      <p:pic>
+        <p:nvPicPr>
+          <p:cNvPr id="50" name="Picture 49" descr="r3.png"/>
+          <p:cNvPicPr>
+            <a:picLocks noChangeAspect="1"/>
+          </p:cNvPicPr>
           <p:nvPr/>
-        </p:nvSpPr>
-        <p:spPr>
-          <a:xfrm>
-            <a:off x="8311895" y="5394960"/>
-            <a:ext cx="868680" cy="685800"/>
-          </a:xfrm>
-          <a:prstGeom prst="roundRect">
+        </p:nvPicPr>
+        <p:blipFill>
+          <a:blip r:embed="rId11"/>
+          <a:stretch>
+            <a:fillRect/>
+          </a:stretch>
+        </p:blipFill>
+        <p:spPr>
+          <a:xfrm>
+            <a:off x="8449055" y="5440680"/>
+            <a:ext cx="640080" cy="640080"/>
+          </a:xfrm>
+          <a:prstGeom prst="rect">
             <a:avLst/>
           </a:prstGeom>
-          <a:solidFill>
-            <a:srgbClr val="FFFFFF"/>
-          </a:solidFill>
-          <a:ln w="19050">
-            <a:solidFill>
-              <a:srgbClr val="868E96"/>
-            </a:solidFill>
-            <a:prstDash val="dash"/>
-          </a:ln>
-        </p:spPr>
-        <p:style>
-          <a:lnRef idx="1">
-            <a:schemeClr val="accent1"/>
-          </a:lnRef>
-          <a:fillRef idx="3">
-            <a:schemeClr val="accent1"/>
-          </a:fillRef>
-          <a:effectRef idx="2">
-            <a:schemeClr val="accent1"/>
-          </a:effectRef>
-          <a:fontRef idx="minor">
-            <a:schemeClr val="lt1"/>
-          </a:fontRef>
-        </p:style>
-        <p:txBody>
-          <a:bodyPr rtlCol="0" anchor="ctr" lIns="73152" rIns="73152" wrap="square"/>
-          <a:lstStyle/>
-          <a:p>
-            <a:pPr algn="ctr"/>
-            <a:r>
-              <a:rPr sz="1100" b="0" i="1">
-                <a:solidFill>
-                  <a:srgbClr val="868E96"/>
-                </a:solidFill>
-              </a:rPr>
-              <a:t>[PIC:</a:t>
-            </a:r>
-          </a:p>
-          <a:p>
-            <a:pPr algn="ctr"/>
-            <a:r>
-              <a:rPr sz="1100" b="0" i="1">
-                <a:solidFill>
-                  <a:srgbClr val="868E96"/>
-                </a:solidFill>
-              </a:rPr>
-              <a:t>🛡 shield]</a:t>
-            </a:r>
-          </a:p>
-        </p:txBody>
-      </p:sp>
-      <p:sp>
-        <p:nvSpPr>
-          <p:cNvPr id="43" name="TextBox 42"/>
+        </p:spPr>
+      </p:pic>
+      <p:sp>
+        <p:nvSpPr>
+          <p:cNvPr id="51" name="TextBox 50"/>
           <p:cNvSpPr txBox="1"/>
           <p:nvPr/>
         </p:nvSpPr>
         <p:spPr>
           <a:xfrm>
-            <a:off x="9272015" y="5440680"/>
+            <a:off x="9226295" y="5440680"/>
             <a:ext cx="2715768" cy="640080"/>
           </a:xfrm>
           <a:prstGeom prst="rect">
@@ -5149,7 +5120,7 @@
       </p:sp>
       <p:sp>
         <p:nvSpPr>
-          <p:cNvPr id="44" name="Rounded Rectangle 43"/>
+          <p:cNvPr id="52" name="Rounded Rectangle 51"/>
           <p:cNvSpPr/>
           <p:nvPr/>
         </p:nvSpPr>

</xml_diff>

<commit_message>
Figure 1 PPT: 3-wrong/1-right, bolder Model labels, Comic Sans
- Switch to 3 wrong + 1 correct (Models 1/2/3 say Sydney, Model 4 Canberra)
- Model N labels: bold navy, font size 15 (was grey 11)
- Apply Comic Sans MS across all text for cartoon feel
</commit_message>
<xml_diff>
--- a/fig1_thesis.pptx
+++ b/fig1_thesis.pptx
@@ -3135,6 +3135,7 @@
                 <a:solidFill>
                   <a:srgbClr val="212529"/>
                 </a:solidFill>
+                <a:latin typeface="Comic Sans MS"/>
               </a:rPr>
               <a:t>A family score says "Knowledge: low."   But WHICH capacity is the bottleneck?</a:t>
             </a:r>
@@ -3188,6 +3189,7 @@
                 <a:solidFill>
                   <a:srgbClr val="1971C2"/>
                 </a:solidFill>
+                <a:latin typeface="Comic Sans MS"/>
               </a:rPr>
               <a:t>Q:  capital of</a:t>
             </a:r>
@@ -3199,6 +3201,7 @@
                 <a:solidFill>
                   <a:srgbClr val="1971C2"/>
                 </a:solidFill>
+                <a:latin typeface="Comic Sans MS"/>
               </a:rPr>
               <a:t>Australia?</a:t>
             </a:r>
@@ -3210,6 +3213,7 @@
                 <a:solidFill>
                   <a:srgbClr val="1971C2"/>
                 </a:solidFill>
+                <a:latin typeface="Comic Sans MS"/>
               </a:rPr>
               <a:t/>
             </a:r>
@@ -3221,6 +3225,7 @@
                 <a:solidFill>
                   <a:srgbClr val="1971C2"/>
                 </a:solidFill>
+                <a:latin typeface="Comic Sans MS"/>
               </a:rPr>
               <a:t>Gold: Canberra</a:t>
             </a:r>
@@ -3310,6 +3315,7 @@
                 <a:solidFill>
                   <a:srgbClr val="212529"/>
                 </a:solidFill>
+                <a:latin typeface="Comic Sans MS"/>
               </a:rPr>
               <a:t/>
             </a:r>
@@ -3348,8 +3354,8 @@
         </p:nvSpPr>
         <p:spPr>
           <a:xfrm>
-            <a:off x="2926080" y="1709928"/>
-            <a:ext cx="2240280" cy="164592"/>
+            <a:off x="2926080" y="1673352"/>
+            <a:ext cx="2240280" cy="219456"/>
           </a:xfrm>
           <a:prstGeom prst="rect">
             <a:avLst/>
@@ -3364,10 +3370,11 @@
           <a:p>
             <a:pPr algn="ctr"/>
             <a:r>
-              <a:rPr sz="1100" b="0" i="0">
-                <a:solidFill>
-                  <a:srgbClr val="868E96"/>
-                </a:solidFill>
+              <a:rPr sz="1500" b="1" i="0">
+                <a:solidFill>
+                  <a:srgbClr val="212529"/>
+                </a:solidFill>
+                <a:latin typeface="Comic Sans MS"/>
               </a:rPr>
               <a:t>Model 1</a:t>
             </a:r>
@@ -3421,6 +3428,7 @@
                 <a:solidFill>
                   <a:srgbClr val="C92A2A"/>
                 </a:solidFill>
+                <a:latin typeface="Comic Sans MS"/>
               </a:rPr>
               <a:t>"Sydney"  ✗</a:t>
             </a:r>
@@ -3474,6 +3482,7 @@
                 <a:solidFill>
                   <a:srgbClr val="212529"/>
                 </a:solidFill>
+                <a:latin typeface="Comic Sans MS"/>
               </a:rPr>
               <a:t/>
             </a:r>
@@ -3512,8 +3521,8 @@
         </p:nvSpPr>
         <p:spPr>
           <a:xfrm>
-            <a:off x="5212080" y="1709928"/>
-            <a:ext cx="2240280" cy="164592"/>
+            <a:off x="5212080" y="1673352"/>
+            <a:ext cx="2240280" cy="219456"/>
           </a:xfrm>
           <a:prstGeom prst="rect">
             <a:avLst/>
@@ -3528,10 +3537,11 @@
           <a:p>
             <a:pPr algn="ctr"/>
             <a:r>
-              <a:rPr sz="1100" b="0" i="0">
-                <a:solidFill>
-                  <a:srgbClr val="868E96"/>
-                </a:solidFill>
+              <a:rPr sz="1500" b="1" i="0">
+                <a:solidFill>
+                  <a:srgbClr val="212529"/>
+                </a:solidFill>
+                <a:latin typeface="Comic Sans MS"/>
               </a:rPr>
               <a:t>Model 2</a:t>
             </a:r>
@@ -3585,6 +3595,7 @@
                 <a:solidFill>
                   <a:srgbClr val="C92A2A"/>
                 </a:solidFill>
+                <a:latin typeface="Comic Sans MS"/>
               </a:rPr>
               <a:t>"Sydney"  ✗</a:t>
             </a:r>
@@ -3638,6 +3649,7 @@
                 <a:solidFill>
                   <a:srgbClr val="212529"/>
                 </a:solidFill>
+                <a:latin typeface="Comic Sans MS"/>
               </a:rPr>
               <a:t/>
             </a:r>
@@ -3676,8 +3688,8 @@
         </p:nvSpPr>
         <p:spPr>
           <a:xfrm>
-            <a:off x="7498079" y="1709928"/>
-            <a:ext cx="2240280" cy="164592"/>
+            <a:off x="7498079" y="1673352"/>
+            <a:ext cx="2240280" cy="219456"/>
           </a:xfrm>
           <a:prstGeom prst="rect">
             <a:avLst/>
@@ -3692,10 +3704,11 @@
           <a:p>
             <a:pPr algn="ctr"/>
             <a:r>
-              <a:rPr sz="1100" b="0" i="0">
-                <a:solidFill>
-                  <a:srgbClr val="868E96"/>
-                </a:solidFill>
+              <a:rPr sz="1500" b="1" i="0">
+                <a:solidFill>
+                  <a:srgbClr val="212529"/>
+                </a:solidFill>
+                <a:latin typeface="Comic Sans MS"/>
               </a:rPr>
               <a:t>Model 3</a:t>
             </a:r>
@@ -3717,11 +3730,11 @@
             <a:avLst/>
           </a:prstGeom>
           <a:solidFill>
-            <a:srgbClr val="D3F9D8"/>
+            <a:srgbClr val="FFE3E3"/>
           </a:solidFill>
           <a:ln w="19050">
             <a:solidFill>
-              <a:srgbClr val="2B8A3E"/>
+              <a:srgbClr val="C92A2A"/>
             </a:solidFill>
           </a:ln>
         </p:spPr>
@@ -3747,10 +3760,11 @@
             <a:r>
               <a:rPr sz="1500" b="1" i="0">
                 <a:solidFill>
-                  <a:srgbClr val="2B8A3E"/>
-                </a:solidFill>
+                  <a:srgbClr val="C92A2A"/>
+                </a:solidFill>
+                <a:latin typeface="Comic Sans MS"/>
               </a:rPr>
-              <a:t>"Canberra"  ✓</a:t>
+              <a:t>"Sydney"  ✗</a:t>
             </a:r>
           </a:p>
         </p:txBody>
@@ -3802,6 +3816,7 @@
                 <a:solidFill>
                   <a:srgbClr val="212529"/>
                 </a:solidFill>
+                <a:latin typeface="Comic Sans MS"/>
               </a:rPr>
               <a:t/>
             </a:r>
@@ -3840,8 +3855,8 @@
         </p:nvSpPr>
         <p:spPr>
           <a:xfrm>
-            <a:off x="9784080" y="1709928"/>
-            <a:ext cx="2240280" cy="164592"/>
+            <a:off x="9784080" y="1673352"/>
+            <a:ext cx="2240280" cy="219456"/>
           </a:xfrm>
           <a:prstGeom prst="rect">
             <a:avLst/>
@@ -3856,10 +3871,11 @@
           <a:p>
             <a:pPr algn="ctr"/>
             <a:r>
-              <a:rPr sz="1100" b="0" i="0">
-                <a:solidFill>
-                  <a:srgbClr val="868E96"/>
-                </a:solidFill>
+              <a:rPr sz="1500" b="1" i="0">
+                <a:solidFill>
+                  <a:srgbClr val="212529"/>
+                </a:solidFill>
+                <a:latin typeface="Comic Sans MS"/>
               </a:rPr>
               <a:t>Model 4</a:t>
             </a:r>
@@ -3913,6 +3929,7 @@
                 <a:solidFill>
                   <a:srgbClr val="2B8A3E"/>
                 </a:solidFill>
+                <a:latin typeface="Comic Sans MS"/>
               </a:rPr>
               <a:t>"Canberra"  ✓</a:t>
             </a:r>
@@ -3966,6 +3983,7 @@
                 <a:solidFill>
                   <a:srgbClr val="D6336C"/>
                 </a:solidFill>
+                <a:latin typeface="Comic Sans MS"/>
               </a:rPr>
               <a:t>Why do Models 1 &amp; 2 fail?  Three different atomic capacities → three different causes ↓</a:t>
             </a:r>
@@ -4019,6 +4037,7 @@
                 <a:solidFill>
                   <a:srgbClr val="212529"/>
                 </a:solidFill>
+                <a:latin typeface="Comic Sans MS"/>
               </a:rPr>
               <a:t/>
             </a:r>
@@ -4053,6 +4072,7 @@
                 <a:solidFill>
                   <a:srgbClr val="1971C2"/>
                 </a:solidFill>
+                <a:latin typeface="Comic Sans MS"/>
               </a:rPr>
               <a:t>①  Knowledge Surfacing</a:t>
             </a:r>
@@ -4111,6 +4131,7 @@
                 <a:solidFill>
                   <a:srgbClr val="1971C2"/>
                 </a:solidFill>
+                <a:latin typeface="Comic Sans MS"/>
               </a:rPr>
               <a:t>The model never reliably</a:t>
             </a:r>
@@ -4122,6 +4143,7 @@
                 <a:solidFill>
                   <a:srgbClr val="1971C2"/>
                 </a:solidFill>
+                <a:latin typeface="Comic Sans MS"/>
               </a:rPr>
               <a:t>stored this fact.</a:t>
             </a:r>
@@ -4156,6 +4178,7 @@
                 <a:solidFill>
                   <a:srgbClr val="868E96"/>
                 </a:solidFill>
+                <a:latin typeface="Comic Sans MS"/>
               </a:rPr>
               <a:t>Probe pair:  (no-hint  vs.  fact-in-context)</a:t>
             </a:r>
@@ -4209,6 +4232,7 @@
                 <a:solidFill>
                   <a:srgbClr val="212529"/>
                 </a:solidFill>
+                <a:latin typeface="Comic Sans MS"/>
               </a:rPr>
               <a:t/>
             </a:r>
@@ -4243,6 +4267,7 @@
                 <a:solidFill>
                   <a:srgbClr val="7048E8"/>
                 </a:solidFill>
+                <a:latin typeface="Comic Sans MS"/>
               </a:rPr>
               <a:t>②  Paraphrase Robustness</a:t>
             </a:r>
@@ -4301,6 +4326,7 @@
                 <a:solidFill>
                   <a:srgbClr val="7048E8"/>
                 </a:solidFill>
+                <a:latin typeface="Comic Sans MS"/>
               </a:rPr>
               <a:t>Knows it under one phrasing,</a:t>
             </a:r>
@@ -4312,6 +4338,7 @@
                 <a:solidFill>
                   <a:srgbClr val="7048E8"/>
                 </a:solidFill>
+                <a:latin typeface="Comic Sans MS"/>
               </a:rPr>
               <a:t>fails on another.</a:t>
             </a:r>
@@ -4346,6 +4373,7 @@
                 <a:solidFill>
                   <a:srgbClr val="868E96"/>
                 </a:solidFill>
+                <a:latin typeface="Comic Sans MS"/>
               </a:rPr>
               <a:t>Probe pair:  (original  vs.  paraphrased)</a:t>
             </a:r>
@@ -4399,6 +4427,7 @@
                 <a:solidFill>
                   <a:srgbClr val="212529"/>
                 </a:solidFill>
+                <a:latin typeface="Comic Sans MS"/>
               </a:rPr>
               <a:t/>
             </a:r>
@@ -4433,6 +4462,7 @@
                 <a:solidFill>
                   <a:srgbClr val="D6336C"/>
                 </a:solidFill>
+                <a:latin typeface="Comic Sans MS"/>
               </a:rPr>
               <a:t>③  Wrong-Claim Robustness</a:t>
             </a:r>
@@ -4491,6 +4521,7 @@
                 <a:solidFill>
                   <a:srgbClr val="D6336C"/>
                 </a:solidFill>
+                <a:latin typeface="Comic Sans MS"/>
               </a:rPr>
               <a:t>Prompt plants a wrong claim,</a:t>
             </a:r>
@@ -4502,6 +4533,7 @@
                 <a:solidFill>
                   <a:srgbClr val="D6336C"/>
                 </a:solidFill>
+                <a:latin typeface="Comic Sans MS"/>
               </a:rPr>
               <a:t>model goes along.</a:t>
             </a:r>
@@ -4536,6 +4568,7 @@
                 <a:solidFill>
                   <a:srgbClr val="868E96"/>
                 </a:solidFill>
+                <a:latin typeface="Comic Sans MS"/>
               </a:rPr>
               <a:t>Probe pair:  (clean  vs.  wrong-claim planted)</a:t>
             </a:r>
@@ -4697,6 +4730,7 @@
                 <a:solidFill>
                   <a:srgbClr val="212529"/>
                 </a:solidFill>
+                <a:latin typeface="Comic Sans MS"/>
               </a:rPr>
               <a:t/>
             </a:r>
@@ -4731,6 +4765,7 @@
                 <a:solidFill>
                   <a:srgbClr val="2B8A3E"/>
                 </a:solidFill>
+                <a:latin typeface="Comic Sans MS"/>
               </a:rPr>
               <a:t>Repair</a:t>
             </a:r>
@@ -4789,6 +4824,7 @@
                 <a:solidFill>
                   <a:srgbClr val="2B8A3E"/>
                 </a:solidFill>
+                <a:latin typeface="Comic Sans MS"/>
               </a:rPr>
               <a:t>Add the fact via retrieval</a:t>
             </a:r>
@@ -4800,6 +4836,7 @@
                 <a:solidFill>
                   <a:srgbClr val="2B8A3E"/>
                 </a:solidFill>
+                <a:latin typeface="Comic Sans MS"/>
               </a:rPr>
               <a:t>or targeted fine-tuning.</a:t>
             </a:r>
@@ -4853,6 +4890,7 @@
                 <a:solidFill>
                   <a:srgbClr val="212529"/>
                 </a:solidFill>
+                <a:latin typeface="Comic Sans MS"/>
               </a:rPr>
               <a:t/>
             </a:r>
@@ -4887,6 +4925,7 @@
                 <a:solidFill>
                   <a:srgbClr val="2B8A3E"/>
                 </a:solidFill>
+                <a:latin typeface="Comic Sans MS"/>
               </a:rPr>
               <a:t>Repair</a:t>
             </a:r>
@@ -4945,6 +4984,7 @@
                 <a:solidFill>
                   <a:srgbClr val="2B8A3E"/>
                 </a:solidFill>
+                <a:latin typeface="Comic Sans MS"/>
               </a:rPr>
               <a:t>Paraphrase-augmented</a:t>
             </a:r>
@@ -4956,6 +4996,7 @@
                 <a:solidFill>
                   <a:srgbClr val="2B8A3E"/>
                 </a:solidFill>
+                <a:latin typeface="Comic Sans MS"/>
               </a:rPr>
               <a:t>pre-training.</a:t>
             </a:r>
@@ -5009,6 +5050,7 @@
                 <a:solidFill>
                   <a:srgbClr val="212529"/>
                 </a:solidFill>
+                <a:latin typeface="Comic Sans MS"/>
               </a:rPr>
               <a:t/>
             </a:r>
@@ -5043,6 +5085,7 @@
                 <a:solidFill>
                   <a:srgbClr val="2B8A3E"/>
                 </a:solidFill>
+                <a:latin typeface="Comic Sans MS"/>
               </a:rPr>
               <a:t>Repair</a:t>
             </a:r>
@@ -5101,6 +5144,7 @@
                 <a:solidFill>
                   <a:srgbClr val="2B8A3E"/>
                 </a:solidFill>
+                <a:latin typeface="Comic Sans MS"/>
               </a:rPr>
               <a:t>Guarded decoding /</a:t>
             </a:r>
@@ -5112,6 +5156,7 @@
                 <a:solidFill>
                   <a:srgbClr val="2B8A3E"/>
                 </a:solidFill>
+                <a:latin typeface="Comic Sans MS"/>
               </a:rPr>
               <a:t>contradiction filter.</a:t>
             </a:r>
@@ -5165,6 +5210,7 @@
                 <a:solidFill>
                   <a:srgbClr val="212529"/>
                 </a:solidFill>
+                <a:latin typeface="Comic Sans MS"/>
               </a:rPr>
               <a:t>Same family score  →  different atomic-capacity bottleneck  →  different repair.</a:t>
             </a:r>

</xml_diff>